<commit_message>
Reorder presentation flow and clarify model and data scope
</commit_message>
<xml_diff>
--- a/docs/G045_Final_Report.pptx
+++ b/docs/G045_Final_Report.pptx
@@ -2,23 +2,23 @@
 <file path=ppt/presentation.xml><?xml version="1.0" encoding="utf-8"?>
 <p:presentation xmlns:p="http://schemas.openxmlformats.org/presentationml/2006/main">
   <p:sldMasterIdLst>
-    <p:sldMasterId xmlns:r="http://schemas.openxmlformats.org/officeDocument/2006/relationships" id="2147483648" r:id="R75ee22baeb13456d"/>
+    <p:sldMasterId xmlns:r="http://schemas.openxmlformats.org/officeDocument/2006/relationships" id="2147483648" r:id="R9c7880c63f1f4188"/>
   </p:sldMasterIdLst>
   <p:notesMasterIdLst>
-    <p:notesMasterId xmlns:r="http://schemas.openxmlformats.org/officeDocument/2006/relationships" r:id="R1c964d5fa64e4b86"/>
+    <p:notesMasterId xmlns:r="http://schemas.openxmlformats.org/officeDocument/2006/relationships" r:id="Rf3d7b74dab1447b6"/>
   </p:notesMasterIdLst>
   <p:sldIdLst>
-    <p:sldId xmlns:r="http://schemas.openxmlformats.org/officeDocument/2006/relationships" id="256" r:id="R7acde66ba3994532"/>
-    <p:sldId xmlns:r="http://schemas.openxmlformats.org/officeDocument/2006/relationships" id="257" r:id="R7ecfd472561c47ba"/>
-    <p:sldId xmlns:r="http://schemas.openxmlformats.org/officeDocument/2006/relationships" id="258" r:id="R7c13b3faf0624f98"/>
-    <p:sldId xmlns:r="http://schemas.openxmlformats.org/officeDocument/2006/relationships" id="259" r:id="Rdc0be74750c84524"/>
-    <p:sldId xmlns:r="http://schemas.openxmlformats.org/officeDocument/2006/relationships" id="260" r:id="R61dd9dbb24de4660"/>
-    <p:sldId xmlns:r="http://schemas.openxmlformats.org/officeDocument/2006/relationships" id="261" r:id="R995dc81cfbbb43bf"/>
-    <p:sldId xmlns:r="http://schemas.openxmlformats.org/officeDocument/2006/relationships" id="262" r:id="R9b49cdf9c2994b3e"/>
-    <p:sldId xmlns:r="http://schemas.openxmlformats.org/officeDocument/2006/relationships" id="263" r:id="R7005562517124fb8"/>
-    <p:sldId xmlns:r="http://schemas.openxmlformats.org/officeDocument/2006/relationships" id="264" r:id="Rba69c251f3b9474b"/>
-    <p:sldId xmlns:r="http://schemas.openxmlformats.org/officeDocument/2006/relationships" id="265" r:id="Ra2e801e859f8467e"/>
-    <p:sldId xmlns:r="http://schemas.openxmlformats.org/officeDocument/2006/relationships" id="266" r:id="Rda20a2c62fe446c1"/>
+    <p:sldId xmlns:r="http://schemas.openxmlformats.org/officeDocument/2006/relationships" id="256" r:id="Raa07c3e7d5ae42b2"/>
+    <p:sldId xmlns:r="http://schemas.openxmlformats.org/officeDocument/2006/relationships" id="257" r:id="R9e3157c567bf4a47"/>
+    <p:sldId xmlns:r="http://schemas.openxmlformats.org/officeDocument/2006/relationships" id="258" r:id="R31f4a1342f8941a8"/>
+    <p:sldId xmlns:r="http://schemas.openxmlformats.org/officeDocument/2006/relationships" id="259" r:id="R9f9a094d58714849"/>
+    <p:sldId xmlns:r="http://schemas.openxmlformats.org/officeDocument/2006/relationships" id="260" r:id="R791f850db00140cd"/>
+    <p:sldId xmlns:r="http://schemas.openxmlformats.org/officeDocument/2006/relationships" id="261" r:id="R6c31c12ab5274489"/>
+    <p:sldId xmlns:r="http://schemas.openxmlformats.org/officeDocument/2006/relationships" id="262" r:id="Re60539d530d54cbc"/>
+    <p:sldId xmlns:r="http://schemas.openxmlformats.org/officeDocument/2006/relationships" id="263" r:id="R7a9359b141f646c5"/>
+    <p:sldId xmlns:r="http://schemas.openxmlformats.org/officeDocument/2006/relationships" id="264" r:id="Rfaf88703657e459c"/>
+    <p:sldId xmlns:r="http://schemas.openxmlformats.org/officeDocument/2006/relationships" id="265" r:id="R40cacff2046f46a9"/>
+    <p:sldId xmlns:r="http://schemas.openxmlformats.org/officeDocument/2006/relationships" id="266" r:id="R58be89ab509542ce"/>
   </p:sldIdLst>
   <p:sldSz cx="7559993" cy="10691813"/>
   <p:notesSz cx="6858000" cy="9144000"/>
@@ -457,7 +457,7 @@
           </a:p>
           <a:p xmlns:a="http://schemas.openxmlformats.org/drawingml/2006/main">
             <a:r>
-              <a:t>5분 발표는 별도 발표 PPTX 본문1~12장,13~17장은 질문용 부록. 이 보고서는 PDF 페이지의 레이아웃을 보존한 이미지 사본입니다. 수정할 원문은 REPORT.md입니다.</a:t>
+              <a:t>5분 발표는 별도 발표 PPTX 1~16장 설명,17장은 기술 대응표 소개와 마무리. 이 보고서는 PDF 페이지의 레이아웃을 보존한 이미지 사본입니다. 수정할 원문은 REPORT.md입니다.</a:t>
             </a:r>
           </a:p>
         </p:txBody>
@@ -532,7 +532,7 @@
           </a:p>
           <a:p xmlns:a="http://schemas.openxmlformats.org/drawingml/2006/main">
             <a:r>
-              <a:t>5분 발표는 별도 발표 PPTX 본문1~12장,13~17장은 질문용 부록. 이 보고서는 PDF 페이지의 레이아웃을 보존한 이미지 사본입니다. 수정할 원문은 REPORT.md입니다.</a:t>
+              <a:t>5분 발표는 별도 발표 PPTX 1~16장 설명,17장은 기술 대응표 소개와 마무리. 이 보고서는 PDF 페이지의 레이아웃을 보존한 이미지 사본입니다. 수정할 원문은 REPORT.md입니다.</a:t>
             </a:r>
           </a:p>
         </p:txBody>
@@ -607,7 +607,7 @@
           </a:p>
           <a:p xmlns:a="http://schemas.openxmlformats.org/drawingml/2006/main">
             <a:r>
-              <a:t>5분 발표는 별도 발표 PPTX 본문1~12장,13~17장은 질문용 부록. 이 보고서는 PDF 페이지의 레이아웃을 보존한 이미지 사본입니다. 수정할 원문은 REPORT.md입니다.</a:t>
+              <a:t>5분 발표는 별도 발표 PPTX 1~16장 설명,17장은 기술 대응표 소개와 마무리. 이 보고서는 PDF 페이지의 레이아웃을 보존한 이미지 사본입니다. 수정할 원문은 REPORT.md입니다.</a:t>
             </a:r>
           </a:p>
         </p:txBody>
@@ -682,7 +682,7 @@
           </a:p>
           <a:p xmlns:a="http://schemas.openxmlformats.org/drawingml/2006/main">
             <a:r>
-              <a:t>5분 발표는 별도 발표 PPTX 본문1~12장,13~17장은 질문용 부록. 이 보고서는 PDF 페이지의 레이아웃을 보존한 이미지 사본입니다. 수정할 원문은 REPORT.md입니다.</a:t>
+              <a:t>5분 발표는 별도 발표 PPTX 1~16장 설명,17장은 기술 대응표 소개와 마무리. 이 보고서는 PDF 페이지의 레이아웃을 보존한 이미지 사본입니다. 수정할 원문은 REPORT.md입니다.</a:t>
             </a:r>
           </a:p>
         </p:txBody>
@@ -757,7 +757,7 @@
           </a:p>
           <a:p xmlns:a="http://schemas.openxmlformats.org/drawingml/2006/main">
             <a:r>
-              <a:t>5분 발표는 별도 발표 PPTX 본문1~12장,13~17장은 질문용 부록. 이 보고서는 PDF 페이지의 레이아웃을 보존한 이미지 사본입니다. 수정할 원문은 REPORT.md입니다.</a:t>
+              <a:t>5분 발표는 별도 발표 PPTX 1~16장 설명,17장은 기술 대응표 소개와 마무리. 이 보고서는 PDF 페이지의 레이아웃을 보존한 이미지 사본입니다. 수정할 원문은 REPORT.md입니다.</a:t>
             </a:r>
           </a:p>
         </p:txBody>
@@ -832,7 +832,7 @@
           </a:p>
           <a:p xmlns:a="http://schemas.openxmlformats.org/drawingml/2006/main">
             <a:r>
-              <a:t>5분 발표는 별도 발표 PPTX 본문1~12장,13~17장은 질문용 부록. 이 보고서는 PDF 페이지의 레이아웃을 보존한 이미지 사본입니다. 수정할 원문은 REPORT.md입니다.</a:t>
+              <a:t>5분 발표는 별도 발표 PPTX 1~16장 설명,17장은 기술 대응표 소개와 마무리. 이 보고서는 PDF 페이지의 레이아웃을 보존한 이미지 사본입니다. 수정할 원문은 REPORT.md입니다.</a:t>
             </a:r>
           </a:p>
         </p:txBody>
@@ -907,7 +907,7 @@
           </a:p>
           <a:p xmlns:a="http://schemas.openxmlformats.org/drawingml/2006/main">
             <a:r>
-              <a:t>5분 발표는 별도 발표 PPTX 본문1~12장,13~17장은 질문용 부록. 이 보고서는 PDF 페이지의 레이아웃을 보존한 이미지 사본입니다. 수정할 원문은 REPORT.md입니다.</a:t>
+              <a:t>5분 발표는 별도 발표 PPTX 1~16장 설명,17장은 기술 대응표 소개와 마무리. 이 보고서는 PDF 페이지의 레이아웃을 보존한 이미지 사본입니다. 수정할 원문은 REPORT.md입니다.</a:t>
             </a:r>
           </a:p>
         </p:txBody>
@@ -982,7 +982,7 @@
           </a:p>
           <a:p xmlns:a="http://schemas.openxmlformats.org/drawingml/2006/main">
             <a:r>
-              <a:t>5분 발표는 별도 발표 PPTX 본문1~12장,13~17장은 질문용 부록. 이 보고서는 PDF 페이지의 레이아웃을 보존한 이미지 사본입니다. 수정할 원문은 REPORT.md입니다.</a:t>
+              <a:t>5분 발표는 별도 발표 PPTX 1~16장 설명,17장은 기술 대응표 소개와 마무리. 이 보고서는 PDF 페이지의 레이아웃을 보존한 이미지 사본입니다. 수정할 원문은 REPORT.md입니다.</a:t>
             </a:r>
           </a:p>
         </p:txBody>
@@ -1057,7 +1057,7 @@
           </a:p>
           <a:p xmlns:a="http://schemas.openxmlformats.org/drawingml/2006/main">
             <a:r>
-              <a:t>5분 발표는 별도 발표 PPTX 본문1~12장,13~17장은 질문용 부록. 이 보고서는 PDF 페이지의 레이아웃을 보존한 이미지 사본입니다. 수정할 원문은 REPORT.md입니다.</a:t>
+              <a:t>5분 발표는 별도 발표 PPTX 1~16장 설명,17장은 기술 대응표 소개와 마무리. 이 보고서는 PDF 페이지의 레이아웃을 보존한 이미지 사본입니다. 수정할 원문은 REPORT.md입니다.</a:t>
             </a:r>
           </a:p>
         </p:txBody>
@@ -1132,7 +1132,7 @@
           </a:p>
           <a:p xmlns:a="http://schemas.openxmlformats.org/drawingml/2006/main">
             <a:r>
-              <a:t>5분 발표는 별도 발표 PPTX 본문1~12장,13~17장은 질문용 부록. 이 보고서는 PDF 페이지의 레이아웃을 보존한 이미지 사본입니다. 수정할 원문은 REPORT.md입니다.</a:t>
+              <a:t>5분 발표는 별도 발표 PPTX 1~16장 설명,17장은 기술 대응표 소개와 마무리. 이 보고서는 PDF 페이지의 레이아웃을 보존한 이미지 사본입니다. 수정할 원문은 REPORT.md입니다.</a:t>
             </a:r>
           </a:p>
         </p:txBody>
@@ -1207,7 +1207,7 @@
           </a:p>
           <a:p xmlns:a="http://schemas.openxmlformats.org/drawingml/2006/main">
             <a:r>
-              <a:t>5분 발표는 별도 발표 PPTX 본문1~12장,13~17장은 질문용 부록. 이 보고서는 PDF 페이지의 레이아웃을 보존한 이미지 사본입니다. 수정할 원문은 REPORT.md입니다.</a:t>
+              <a:t>5분 발표는 별도 발표 PPTX 1~16장 설명,17장은 기술 대응표 소개와 마무리. 이 보고서는 PDF 페이지의 레이아웃을 보존한 이미지 사본입니다. 수정할 원문은 REPORT.md입니다.</a:t>
             </a:r>
           </a:p>
         </p:txBody>
@@ -1254,7 +1254,7 @@
           <p:cNvPr id="3" name="Title">
             <a:extLst xmlns:a="http://schemas.openxmlformats.org/drawingml/2006/main">
               <a:ext uri="{FF2B5EF4-FFF2-40B4-BE49-F238E27FC236}">
-                <a16:creationId xmlns:a16="http://schemas.microsoft.com/office/drawing/2014/main" id="{3E9F763B-CE75-4D7D-96AC-C1168263B609}"/>
+                <a16:creationId xmlns:a16="http://schemas.microsoft.com/office/drawing/2014/main" id="{548BB746-670E-44C9-840F-DA2E9B6B5F04}"/>
               </a:ext>
             </a:extLst>
           </p:cNvPr>
@@ -1483,7 +1483,7 @@
           <p:cNvPr id="2" name="Subtitle">
             <a:extLst xmlns:a="http://schemas.openxmlformats.org/drawingml/2006/main">
               <a:ext uri="{FF2B5EF4-FFF2-40B4-BE49-F238E27FC236}">
-                <a16:creationId xmlns:a16="http://schemas.microsoft.com/office/drawing/2014/main" id="{8DB893FD-7DF5-45EF-8075-308B919BFE8A}"/>
+                <a16:creationId xmlns:a16="http://schemas.microsoft.com/office/drawing/2014/main" id="{366D5C18-E433-4D71-97BB-F17CCB9CB107}"/>
               </a:ext>
             </a:extLst>
           </p:cNvPr>
@@ -1729,7 +1729,7 @@
           <p:cNvPr id="2" name="Section title">
             <a:extLst xmlns:a="http://schemas.openxmlformats.org/drawingml/2006/main">
               <a:ext uri="{FF2B5EF4-FFF2-40B4-BE49-F238E27FC236}">
-                <a16:creationId xmlns:a16="http://schemas.microsoft.com/office/drawing/2014/main" id="{45FD98A4-727D-4EC5-9C51-606FC9BD54F7}"/>
+                <a16:creationId xmlns:a16="http://schemas.microsoft.com/office/drawing/2014/main" id="{A8696AFD-9036-40B8-8336-8842DA82AB93}"/>
               </a:ext>
             </a:extLst>
           </p:cNvPr>
@@ -1975,7 +1975,7 @@
           <p:cNvPr id="3" name="Title">
             <a:extLst xmlns:a="http://schemas.openxmlformats.org/drawingml/2006/main">
               <a:ext uri="{FF2B5EF4-FFF2-40B4-BE49-F238E27FC236}">
-                <a16:creationId xmlns:a16="http://schemas.microsoft.com/office/drawing/2014/main" id="{44CF737C-7EA4-442A-9168-F84F20B49236}"/>
+                <a16:creationId xmlns:a16="http://schemas.microsoft.com/office/drawing/2014/main" id="{90B86598-8A56-46A9-8008-C94F1696865D}"/>
               </a:ext>
             </a:extLst>
           </p:cNvPr>
@@ -2204,7 +2204,7 @@
           <p:cNvPr id="2" name="Body">
             <a:extLst xmlns:a="http://schemas.openxmlformats.org/drawingml/2006/main">
               <a:ext uri="{FF2B5EF4-FFF2-40B4-BE49-F238E27FC236}">
-                <a16:creationId xmlns:a16="http://schemas.microsoft.com/office/drawing/2014/main" id="{3145C6D6-F5EB-4ECC-9777-C22A8E9CE07A}"/>
+                <a16:creationId xmlns:a16="http://schemas.microsoft.com/office/drawing/2014/main" id="{BC601FD6-7C59-44F1-B400-43B27217E19A}"/>
               </a:ext>
             </a:extLst>
           </p:cNvPr>
@@ -2450,7 +2450,7 @@
           <p:cNvPr id="4" name="Title">
             <a:extLst xmlns:a="http://schemas.openxmlformats.org/drawingml/2006/main">
               <a:ext uri="{FF2B5EF4-FFF2-40B4-BE49-F238E27FC236}">
-                <a16:creationId xmlns:a16="http://schemas.microsoft.com/office/drawing/2014/main" id="{033DD849-EA3E-4D0D-B89C-324448C51D1D}"/>
+                <a16:creationId xmlns:a16="http://schemas.microsoft.com/office/drawing/2014/main" id="{6356BA92-E251-4D81-B428-89D34E885E16}"/>
               </a:ext>
             </a:extLst>
           </p:cNvPr>
@@ -2679,7 +2679,7 @@
           <p:cNvPr id="2" name="Left column">
             <a:extLst xmlns:a="http://schemas.openxmlformats.org/drawingml/2006/main">
               <a:ext uri="{FF2B5EF4-FFF2-40B4-BE49-F238E27FC236}">
-                <a16:creationId xmlns:a16="http://schemas.microsoft.com/office/drawing/2014/main" id="{B0BBB5B5-520A-45EF-87A2-76BD545C0F0F}"/>
+                <a16:creationId xmlns:a16="http://schemas.microsoft.com/office/drawing/2014/main" id="{80BCC535-E5EF-4689-A7EB-4F1424FC50C7}"/>
               </a:ext>
             </a:extLst>
           </p:cNvPr>
@@ -2908,7 +2908,7 @@
           <p:cNvPr id="3" name="Right column">
             <a:extLst xmlns:a="http://schemas.openxmlformats.org/drawingml/2006/main">
               <a:ext uri="{FF2B5EF4-FFF2-40B4-BE49-F238E27FC236}">
-                <a16:creationId xmlns:a16="http://schemas.microsoft.com/office/drawing/2014/main" id="{4C218DAE-527F-42E2-885B-218790F59FBF}"/>
+                <a16:creationId xmlns:a16="http://schemas.microsoft.com/office/drawing/2014/main" id="{292B415D-874C-4CFD-B7E0-54A0331384AA}"/>
               </a:ext>
             </a:extLst>
           </p:cNvPr>
@@ -3154,7 +3154,7 @@
           <p:cNvPr id="3" name="Title">
             <a:extLst xmlns:a="http://schemas.openxmlformats.org/drawingml/2006/main">
               <a:ext uri="{FF2B5EF4-FFF2-40B4-BE49-F238E27FC236}">
-                <a16:creationId xmlns:a16="http://schemas.microsoft.com/office/drawing/2014/main" id="{052D9C41-88B6-49CA-89DF-497E0B8BB4A7}"/>
+                <a16:creationId xmlns:a16="http://schemas.microsoft.com/office/drawing/2014/main" id="{8759C848-492C-4C35-8D6B-A61AB076E9AD}"/>
               </a:ext>
             </a:extLst>
           </p:cNvPr>
@@ -3383,7 +3383,7 @@
           <p:cNvPr id="2" name="Left column">
             <a:extLst xmlns:a="http://schemas.openxmlformats.org/drawingml/2006/main">
               <a:ext uri="{FF2B5EF4-FFF2-40B4-BE49-F238E27FC236}">
-                <a16:creationId xmlns:a16="http://schemas.microsoft.com/office/drawing/2014/main" id="{50104673-E8FD-4373-BCCC-ED2FDACC5972}"/>
+                <a16:creationId xmlns:a16="http://schemas.microsoft.com/office/drawing/2014/main" id="{255F9FD9-A152-49B3-8CCE-B5DA65FEB2AD}"/>
               </a:ext>
             </a:extLst>
           </p:cNvPr>
@@ -3650,12 +3650,12 @@
   </p:cSld>
   <p:clrMap bg1="lt1" tx1="dk1" bg2="lt2" tx2="dk2" accent1="accent1" accent2="accent2" accent3="accent3" accent4="accent4" accent5="accent5" accent6="accent6" hlink="hlink" folHlink="folHlink"/>
   <p:sldLayoutIdLst>
-    <p:sldLayoutId xmlns:r="http://schemas.openxmlformats.org/officeDocument/2006/relationships" id="2147483649" r:id="R394c09a0b58f4004"/>
-    <p:sldLayoutId xmlns:r="http://schemas.openxmlformats.org/officeDocument/2006/relationships" id="2147483650" r:id="Rf5493b97ca1442d0"/>
-    <p:sldLayoutId xmlns:r="http://schemas.openxmlformats.org/officeDocument/2006/relationships" id="2147483651" r:id="Rb9c8cfafbf944631"/>
-    <p:sldLayoutId xmlns:r="http://schemas.openxmlformats.org/officeDocument/2006/relationships" id="2147483652" r:id="Rf4a8a7a43cfd4a83"/>
-    <p:sldLayoutId xmlns:r="http://schemas.openxmlformats.org/officeDocument/2006/relationships" id="2147483653" r:id="R13bd118103c94ef5"/>
-    <p:sldLayoutId xmlns:r="http://schemas.openxmlformats.org/officeDocument/2006/relationships" id="2147483654" r:id="Rb8f349d4def64221"/>
+    <p:sldLayoutId xmlns:r="http://schemas.openxmlformats.org/officeDocument/2006/relationships" id="2147483649" r:id="Ra4a97203473a4171"/>
+    <p:sldLayoutId xmlns:r="http://schemas.openxmlformats.org/officeDocument/2006/relationships" id="2147483650" r:id="R9838cb1f32f14cb8"/>
+    <p:sldLayoutId xmlns:r="http://schemas.openxmlformats.org/officeDocument/2006/relationships" id="2147483651" r:id="R33ae7f89ed414a32"/>
+    <p:sldLayoutId xmlns:r="http://schemas.openxmlformats.org/officeDocument/2006/relationships" id="2147483652" r:id="Ra23aca2a78e24fe7"/>
+    <p:sldLayoutId xmlns:r="http://schemas.openxmlformats.org/officeDocument/2006/relationships" id="2147483653" r:id="Rbb4958655ec14aa3"/>
+    <p:sldLayoutId xmlns:r="http://schemas.openxmlformats.org/officeDocument/2006/relationships" id="2147483654" r:id="R554c6d8dd6b14b9b"/>
   </p:sldLayoutIdLst>
   <p:txStyles>
     <p:titleStyle>
@@ -4199,7 +4199,7 @@
           <p:cNvPr id="2" name="">
             <a:extLst xmlns:a="http://schemas.openxmlformats.org/drawingml/2006/main">
               <a:ext uri="{FF2B5EF4-FFF2-40B4-BE49-F238E27FC236}">
-                <a16:creationId xmlns:a16="http://schemas.microsoft.com/office/drawing/2014/main" id="{585D233E-78A5-4357-91FB-921E8932AD90}"/>
+                <a16:creationId xmlns:a16="http://schemas.microsoft.com/office/drawing/2014/main" id="{B372673C-C3E9-46B1-99FB-FA43F233CD19}"/>
               </a:ext>
             </a:extLst>
           </p:cNvPr>
@@ -4209,7 +4209,7 @@
           <p:nvPr/>
         </p:nvPicPr>
         <p:blipFill>
-          <a:blip xmlns:r="http://schemas.openxmlformats.org/officeDocument/2006/relationships" xmlns:a="http://schemas.openxmlformats.org/drawingml/2006/main" r:embed="R1d1a076252c5450e"/>
+          <a:blip xmlns:r="http://schemas.openxmlformats.org/officeDocument/2006/relationships" xmlns:a="http://schemas.openxmlformats.org/drawingml/2006/main" r:embed="Re721f7c7f9834134"/>
           <a:stretch xmlns:a="http://schemas.openxmlformats.org/drawingml/2006/main"/>
         </p:blipFill>
         <p:spPr>
@@ -4225,7 +4225,7 @@
     </p:spTree>
     <p:extLst>
       <p:ext uri="{BB962C8B-B14F-4D97-AF65-F5344CB8AC3E}">
-        <p14:creationId xmlns:p14="http://schemas.microsoft.com/office/powerpoint/2010/main" val="677190291"/>
+        <p14:creationId xmlns:p14="http://schemas.microsoft.com/office/powerpoint/2010/main" val="969446606"/>
       </p:ext>
     </p:extLst>
   </p:cSld>
@@ -4249,7 +4249,7 @@
           <p:cNvPr id="2" name="">
             <a:extLst xmlns:a="http://schemas.openxmlformats.org/drawingml/2006/main">
               <a:ext uri="{FF2B5EF4-FFF2-40B4-BE49-F238E27FC236}">
-                <a16:creationId xmlns:a16="http://schemas.microsoft.com/office/drawing/2014/main" id="{625DEE6E-3201-4079-9567-DEC87C9964D8}"/>
+                <a16:creationId xmlns:a16="http://schemas.microsoft.com/office/drawing/2014/main" id="{221324CF-DCBC-44A7-97CF-52945F2FF1FD}"/>
               </a:ext>
             </a:extLst>
           </p:cNvPr>
@@ -4259,7 +4259,7 @@
           <p:nvPr/>
         </p:nvPicPr>
         <p:blipFill>
-          <a:blip xmlns:r="http://schemas.openxmlformats.org/officeDocument/2006/relationships" xmlns:a="http://schemas.openxmlformats.org/drawingml/2006/main" r:embed="R8cdef190ecdf46bd"/>
+          <a:blip xmlns:r="http://schemas.openxmlformats.org/officeDocument/2006/relationships" xmlns:a="http://schemas.openxmlformats.org/drawingml/2006/main" r:embed="Rd18786c0019042f3"/>
           <a:stretch xmlns:a="http://schemas.openxmlformats.org/drawingml/2006/main"/>
         </p:blipFill>
         <p:spPr>
@@ -4275,7 +4275,7 @@
     </p:spTree>
     <p:extLst>
       <p:ext uri="{BB962C8B-B14F-4D97-AF65-F5344CB8AC3E}">
-        <p14:creationId xmlns:p14="http://schemas.microsoft.com/office/powerpoint/2010/main" val="638092005"/>
+        <p14:creationId xmlns:p14="http://schemas.microsoft.com/office/powerpoint/2010/main" val="1999554049"/>
       </p:ext>
     </p:extLst>
   </p:cSld>
@@ -4299,7 +4299,7 @@
           <p:cNvPr id="2" name="">
             <a:extLst xmlns:a="http://schemas.openxmlformats.org/drawingml/2006/main">
               <a:ext uri="{FF2B5EF4-FFF2-40B4-BE49-F238E27FC236}">
-                <a16:creationId xmlns:a16="http://schemas.microsoft.com/office/drawing/2014/main" id="{C25FF1C0-11A4-4EB3-BC9E-B9C6B029CE90}"/>
+                <a16:creationId xmlns:a16="http://schemas.microsoft.com/office/drawing/2014/main" id="{9835FBF7-3541-453E-8B9A-FBB4499BA304}"/>
               </a:ext>
             </a:extLst>
           </p:cNvPr>
@@ -4309,7 +4309,7 @@
           <p:nvPr/>
         </p:nvPicPr>
         <p:blipFill>
-          <a:blip xmlns:r="http://schemas.openxmlformats.org/officeDocument/2006/relationships" xmlns:a="http://schemas.openxmlformats.org/drawingml/2006/main" r:embed="R9bdd21a5c4044ce2"/>
+          <a:blip xmlns:r="http://schemas.openxmlformats.org/officeDocument/2006/relationships" xmlns:a="http://schemas.openxmlformats.org/drawingml/2006/main" r:embed="R0b18344b44e44566"/>
           <a:stretch xmlns:a="http://schemas.openxmlformats.org/drawingml/2006/main"/>
         </p:blipFill>
         <p:spPr>
@@ -4325,7 +4325,7 @@
     </p:spTree>
     <p:extLst>
       <p:ext uri="{BB962C8B-B14F-4D97-AF65-F5344CB8AC3E}">
-        <p14:creationId xmlns:p14="http://schemas.microsoft.com/office/powerpoint/2010/main" val="613588723"/>
+        <p14:creationId xmlns:p14="http://schemas.microsoft.com/office/powerpoint/2010/main" val="1982589386"/>
       </p:ext>
     </p:extLst>
   </p:cSld>
@@ -4349,7 +4349,7 @@
           <p:cNvPr id="2" name="">
             <a:extLst xmlns:a="http://schemas.openxmlformats.org/drawingml/2006/main">
               <a:ext uri="{FF2B5EF4-FFF2-40B4-BE49-F238E27FC236}">
-                <a16:creationId xmlns:a16="http://schemas.microsoft.com/office/drawing/2014/main" id="{A4AAE9DD-0939-4B09-B666-0A6878FACB88}"/>
+                <a16:creationId xmlns:a16="http://schemas.microsoft.com/office/drawing/2014/main" id="{1A2C27B7-F895-4A1F-A2B8-8ADA9C7C83AE}"/>
               </a:ext>
             </a:extLst>
           </p:cNvPr>
@@ -4359,7 +4359,7 @@
           <p:nvPr/>
         </p:nvPicPr>
         <p:blipFill>
-          <a:blip xmlns:r="http://schemas.openxmlformats.org/officeDocument/2006/relationships" xmlns:a="http://schemas.openxmlformats.org/drawingml/2006/main" r:embed="Rf3c3973626264538"/>
+          <a:blip xmlns:r="http://schemas.openxmlformats.org/officeDocument/2006/relationships" xmlns:a="http://schemas.openxmlformats.org/drawingml/2006/main" r:embed="Raea04d16482449f5"/>
           <a:stretch xmlns:a="http://schemas.openxmlformats.org/drawingml/2006/main"/>
         </p:blipFill>
         <p:spPr>
@@ -4375,7 +4375,7 @@
     </p:spTree>
     <p:extLst>
       <p:ext uri="{BB962C8B-B14F-4D97-AF65-F5344CB8AC3E}">
-        <p14:creationId xmlns:p14="http://schemas.microsoft.com/office/powerpoint/2010/main" val="2047036192"/>
+        <p14:creationId xmlns:p14="http://schemas.microsoft.com/office/powerpoint/2010/main" val="1749246965"/>
       </p:ext>
     </p:extLst>
   </p:cSld>
@@ -4399,7 +4399,7 @@
           <p:cNvPr id="2" name="">
             <a:extLst xmlns:a="http://schemas.openxmlformats.org/drawingml/2006/main">
               <a:ext uri="{FF2B5EF4-FFF2-40B4-BE49-F238E27FC236}">
-                <a16:creationId xmlns:a16="http://schemas.microsoft.com/office/drawing/2014/main" id="{0EA4C703-235C-41FF-B3F2-B27235DA2E18}"/>
+                <a16:creationId xmlns:a16="http://schemas.microsoft.com/office/drawing/2014/main" id="{962095CF-25D7-40C5-ABFB-B5143EFAB917}"/>
               </a:ext>
             </a:extLst>
           </p:cNvPr>
@@ -4409,7 +4409,7 @@
           <p:nvPr/>
         </p:nvPicPr>
         <p:blipFill>
-          <a:blip xmlns:r="http://schemas.openxmlformats.org/officeDocument/2006/relationships" xmlns:a="http://schemas.openxmlformats.org/drawingml/2006/main" r:embed="Rf221553996ba4995"/>
+          <a:blip xmlns:r="http://schemas.openxmlformats.org/officeDocument/2006/relationships" xmlns:a="http://schemas.openxmlformats.org/drawingml/2006/main" r:embed="Rb71577dc33b64dc1"/>
           <a:stretch xmlns:a="http://schemas.openxmlformats.org/drawingml/2006/main"/>
         </p:blipFill>
         <p:spPr>
@@ -4425,7 +4425,7 @@
     </p:spTree>
     <p:extLst>
       <p:ext uri="{BB962C8B-B14F-4D97-AF65-F5344CB8AC3E}">
-        <p14:creationId xmlns:p14="http://schemas.microsoft.com/office/powerpoint/2010/main" val="1475337162"/>
+        <p14:creationId xmlns:p14="http://schemas.microsoft.com/office/powerpoint/2010/main" val="1833555837"/>
       </p:ext>
     </p:extLst>
   </p:cSld>
@@ -4449,7 +4449,7 @@
           <p:cNvPr id="2" name="">
             <a:extLst xmlns:a="http://schemas.openxmlformats.org/drawingml/2006/main">
               <a:ext uri="{FF2B5EF4-FFF2-40B4-BE49-F238E27FC236}">
-                <a16:creationId xmlns:a16="http://schemas.microsoft.com/office/drawing/2014/main" id="{CA58EC5E-AB7E-4834-BC0E-67F61543A7A9}"/>
+                <a16:creationId xmlns:a16="http://schemas.microsoft.com/office/drawing/2014/main" id="{717F8E63-7C62-4CA4-B823-3B77602A11D5}"/>
               </a:ext>
             </a:extLst>
           </p:cNvPr>
@@ -4459,7 +4459,7 @@
           <p:nvPr/>
         </p:nvPicPr>
         <p:blipFill>
-          <a:blip xmlns:r="http://schemas.openxmlformats.org/officeDocument/2006/relationships" xmlns:a="http://schemas.openxmlformats.org/drawingml/2006/main" r:embed="Rb3bf45f6b1344334"/>
+          <a:blip xmlns:r="http://schemas.openxmlformats.org/officeDocument/2006/relationships" xmlns:a="http://schemas.openxmlformats.org/drawingml/2006/main" r:embed="Rd59557406f9846b2"/>
           <a:stretch xmlns:a="http://schemas.openxmlformats.org/drawingml/2006/main"/>
         </p:blipFill>
         <p:spPr>
@@ -4475,7 +4475,7 @@
     </p:spTree>
     <p:extLst>
       <p:ext uri="{BB962C8B-B14F-4D97-AF65-F5344CB8AC3E}">
-        <p14:creationId xmlns:p14="http://schemas.microsoft.com/office/powerpoint/2010/main" val="1537107194"/>
+        <p14:creationId xmlns:p14="http://schemas.microsoft.com/office/powerpoint/2010/main" val="418958871"/>
       </p:ext>
     </p:extLst>
   </p:cSld>
@@ -4499,7 +4499,7 @@
           <p:cNvPr id="2" name="">
             <a:extLst xmlns:a="http://schemas.openxmlformats.org/drawingml/2006/main">
               <a:ext uri="{FF2B5EF4-FFF2-40B4-BE49-F238E27FC236}">
-                <a16:creationId xmlns:a16="http://schemas.microsoft.com/office/drawing/2014/main" id="{19E08F23-6966-48A7-8953-56AB51611804}"/>
+                <a16:creationId xmlns:a16="http://schemas.microsoft.com/office/drawing/2014/main" id="{A9238951-1732-4225-B030-B9940270A1E9}"/>
               </a:ext>
             </a:extLst>
           </p:cNvPr>
@@ -4509,7 +4509,7 @@
           <p:nvPr/>
         </p:nvPicPr>
         <p:blipFill>
-          <a:blip xmlns:r="http://schemas.openxmlformats.org/officeDocument/2006/relationships" xmlns:a="http://schemas.openxmlformats.org/drawingml/2006/main" r:embed="R7d7e86d899d14648"/>
+          <a:blip xmlns:r="http://schemas.openxmlformats.org/officeDocument/2006/relationships" xmlns:a="http://schemas.openxmlformats.org/drawingml/2006/main" r:embed="Rfa2df3fc78b24482"/>
           <a:stretch xmlns:a="http://schemas.openxmlformats.org/drawingml/2006/main"/>
         </p:blipFill>
         <p:spPr>
@@ -4525,7 +4525,7 @@
     </p:spTree>
     <p:extLst>
       <p:ext uri="{BB962C8B-B14F-4D97-AF65-F5344CB8AC3E}">
-        <p14:creationId xmlns:p14="http://schemas.microsoft.com/office/powerpoint/2010/main" val="943347240"/>
+        <p14:creationId xmlns:p14="http://schemas.microsoft.com/office/powerpoint/2010/main" val="180792510"/>
       </p:ext>
     </p:extLst>
   </p:cSld>
@@ -4549,7 +4549,7 @@
           <p:cNvPr id="2" name="">
             <a:extLst xmlns:a="http://schemas.openxmlformats.org/drawingml/2006/main">
               <a:ext uri="{FF2B5EF4-FFF2-40B4-BE49-F238E27FC236}">
-                <a16:creationId xmlns:a16="http://schemas.microsoft.com/office/drawing/2014/main" id="{36F4285A-0115-4995-A0A6-AE7016A2CD7B}"/>
+                <a16:creationId xmlns:a16="http://schemas.microsoft.com/office/drawing/2014/main" id="{74ECC7BC-77B1-480A-B155-97BC07AFAFAE}"/>
               </a:ext>
             </a:extLst>
           </p:cNvPr>
@@ -4559,7 +4559,7 @@
           <p:nvPr/>
         </p:nvPicPr>
         <p:blipFill>
-          <a:blip xmlns:r="http://schemas.openxmlformats.org/officeDocument/2006/relationships" xmlns:a="http://schemas.openxmlformats.org/drawingml/2006/main" r:embed="R190a80d15fce453f"/>
+          <a:blip xmlns:r="http://schemas.openxmlformats.org/officeDocument/2006/relationships" xmlns:a="http://schemas.openxmlformats.org/drawingml/2006/main" r:embed="R25d1226a587441c3"/>
           <a:stretch xmlns:a="http://schemas.openxmlformats.org/drawingml/2006/main"/>
         </p:blipFill>
         <p:spPr>
@@ -4575,7 +4575,7 @@
     </p:spTree>
     <p:extLst>
       <p:ext uri="{BB962C8B-B14F-4D97-AF65-F5344CB8AC3E}">
-        <p14:creationId xmlns:p14="http://schemas.microsoft.com/office/powerpoint/2010/main" val="380492427"/>
+        <p14:creationId xmlns:p14="http://schemas.microsoft.com/office/powerpoint/2010/main" val="1619659488"/>
       </p:ext>
     </p:extLst>
   </p:cSld>
@@ -4599,7 +4599,7 @@
           <p:cNvPr id="2" name="">
             <a:extLst xmlns:a="http://schemas.openxmlformats.org/drawingml/2006/main">
               <a:ext uri="{FF2B5EF4-FFF2-40B4-BE49-F238E27FC236}">
-                <a16:creationId xmlns:a16="http://schemas.microsoft.com/office/drawing/2014/main" id="{D3B73678-4038-40E0-9727-4E6F07456FA7}"/>
+                <a16:creationId xmlns:a16="http://schemas.microsoft.com/office/drawing/2014/main" id="{9090D579-EDDD-4C01-87E4-3DBEA5FD4155}"/>
               </a:ext>
             </a:extLst>
           </p:cNvPr>
@@ -4609,7 +4609,7 @@
           <p:nvPr/>
         </p:nvPicPr>
         <p:blipFill>
-          <a:blip xmlns:r="http://schemas.openxmlformats.org/officeDocument/2006/relationships" xmlns:a="http://schemas.openxmlformats.org/drawingml/2006/main" r:embed="R70700c7b972d4b72"/>
+          <a:blip xmlns:r="http://schemas.openxmlformats.org/officeDocument/2006/relationships" xmlns:a="http://schemas.openxmlformats.org/drawingml/2006/main" r:embed="R8841a2ef632f4bff"/>
           <a:stretch xmlns:a="http://schemas.openxmlformats.org/drawingml/2006/main"/>
         </p:blipFill>
         <p:spPr>
@@ -4625,7 +4625,7 @@
     </p:spTree>
     <p:extLst>
       <p:ext uri="{BB962C8B-B14F-4D97-AF65-F5344CB8AC3E}">
-        <p14:creationId xmlns:p14="http://schemas.microsoft.com/office/powerpoint/2010/main" val="1677544216"/>
+        <p14:creationId xmlns:p14="http://schemas.microsoft.com/office/powerpoint/2010/main" val="2019482171"/>
       </p:ext>
     </p:extLst>
   </p:cSld>
@@ -4649,7 +4649,7 @@
           <p:cNvPr id="2" name="">
             <a:extLst xmlns:a="http://schemas.openxmlformats.org/drawingml/2006/main">
               <a:ext uri="{FF2B5EF4-FFF2-40B4-BE49-F238E27FC236}">
-                <a16:creationId xmlns:a16="http://schemas.microsoft.com/office/drawing/2014/main" id="{B75F5E65-1CCF-41FE-9A17-A709126F33C6}"/>
+                <a16:creationId xmlns:a16="http://schemas.microsoft.com/office/drawing/2014/main" id="{7ADD4F94-EE7F-4246-A15E-B8C212B5E29B}"/>
               </a:ext>
             </a:extLst>
           </p:cNvPr>
@@ -4659,7 +4659,7 @@
           <p:nvPr/>
         </p:nvPicPr>
         <p:blipFill>
-          <a:blip xmlns:r="http://schemas.openxmlformats.org/officeDocument/2006/relationships" xmlns:a="http://schemas.openxmlformats.org/drawingml/2006/main" r:embed="R907fe15389bb4c5d"/>
+          <a:blip xmlns:r="http://schemas.openxmlformats.org/officeDocument/2006/relationships" xmlns:a="http://schemas.openxmlformats.org/drawingml/2006/main" r:embed="Rdbde554e6a2b4939"/>
           <a:stretch xmlns:a="http://schemas.openxmlformats.org/drawingml/2006/main"/>
         </p:blipFill>
         <p:spPr>
@@ -4675,7 +4675,7 @@
     </p:spTree>
     <p:extLst>
       <p:ext uri="{BB962C8B-B14F-4D97-AF65-F5344CB8AC3E}">
-        <p14:creationId xmlns:p14="http://schemas.microsoft.com/office/powerpoint/2010/main" val="1801246707"/>
+        <p14:creationId xmlns:p14="http://schemas.microsoft.com/office/powerpoint/2010/main" val="829145902"/>
       </p:ext>
     </p:extLst>
   </p:cSld>
@@ -4699,7 +4699,7 @@
           <p:cNvPr id="2" name="">
             <a:extLst xmlns:a="http://schemas.openxmlformats.org/drawingml/2006/main">
               <a:ext uri="{FF2B5EF4-FFF2-40B4-BE49-F238E27FC236}">
-                <a16:creationId xmlns:a16="http://schemas.microsoft.com/office/drawing/2014/main" id="{025D3249-6DA8-45B5-9AA8-FB829A71F3CD}"/>
+                <a16:creationId xmlns:a16="http://schemas.microsoft.com/office/drawing/2014/main" id="{A3B00F04-5D84-4C58-9165-426F5849D6CE}"/>
               </a:ext>
             </a:extLst>
           </p:cNvPr>
@@ -4709,7 +4709,7 @@
           <p:nvPr/>
         </p:nvPicPr>
         <p:blipFill>
-          <a:blip xmlns:r="http://schemas.openxmlformats.org/officeDocument/2006/relationships" xmlns:a="http://schemas.openxmlformats.org/drawingml/2006/main" r:embed="R36287ac1823146a0"/>
+          <a:blip xmlns:r="http://schemas.openxmlformats.org/officeDocument/2006/relationships" xmlns:a="http://schemas.openxmlformats.org/drawingml/2006/main" r:embed="R0e4556f437a349a7"/>
           <a:stretch xmlns:a="http://schemas.openxmlformats.org/drawingml/2006/main"/>
         </p:blipFill>
         <p:spPr>
@@ -4725,7 +4725,7 @@
     </p:spTree>
     <p:extLst>
       <p:ext uri="{BB962C8B-B14F-4D97-AF65-F5344CB8AC3E}">
-        <p14:creationId xmlns:p14="http://schemas.microsoft.com/office/powerpoint/2010/main" val="464205545"/>
+        <p14:creationId xmlns:p14="http://schemas.microsoft.com/office/powerpoint/2010/main" val="665815716"/>
       </p:ext>
     </p:extLst>
   </p:cSld>

</xml_diff>

<commit_message>
Align final report with model selection explanation
</commit_message>
<xml_diff>
--- a/docs/G045_Final_Report.pptx
+++ b/docs/G045_Final_Report.pptx
@@ -2,23 +2,23 @@
 <file path=ppt/presentation.xml><?xml version="1.0" encoding="utf-8"?>
 <p:presentation xmlns:p="http://schemas.openxmlformats.org/presentationml/2006/main">
   <p:sldMasterIdLst>
-    <p:sldMasterId xmlns:r="http://schemas.openxmlformats.org/officeDocument/2006/relationships" id="2147483648" r:id="R9c7880c63f1f4188"/>
+    <p:sldMasterId xmlns:r="http://schemas.openxmlformats.org/officeDocument/2006/relationships" id="2147483648" r:id="R44f9e8ab32b04b2c"/>
   </p:sldMasterIdLst>
   <p:notesMasterIdLst>
-    <p:notesMasterId xmlns:r="http://schemas.openxmlformats.org/officeDocument/2006/relationships" r:id="Rf3d7b74dab1447b6"/>
+    <p:notesMasterId xmlns:r="http://schemas.openxmlformats.org/officeDocument/2006/relationships" r:id="Rb24e55e960a94bd1"/>
   </p:notesMasterIdLst>
   <p:sldIdLst>
-    <p:sldId xmlns:r="http://schemas.openxmlformats.org/officeDocument/2006/relationships" id="256" r:id="Raa07c3e7d5ae42b2"/>
-    <p:sldId xmlns:r="http://schemas.openxmlformats.org/officeDocument/2006/relationships" id="257" r:id="R9e3157c567bf4a47"/>
-    <p:sldId xmlns:r="http://schemas.openxmlformats.org/officeDocument/2006/relationships" id="258" r:id="R31f4a1342f8941a8"/>
-    <p:sldId xmlns:r="http://schemas.openxmlformats.org/officeDocument/2006/relationships" id="259" r:id="R9f9a094d58714849"/>
-    <p:sldId xmlns:r="http://schemas.openxmlformats.org/officeDocument/2006/relationships" id="260" r:id="R791f850db00140cd"/>
-    <p:sldId xmlns:r="http://schemas.openxmlformats.org/officeDocument/2006/relationships" id="261" r:id="R6c31c12ab5274489"/>
-    <p:sldId xmlns:r="http://schemas.openxmlformats.org/officeDocument/2006/relationships" id="262" r:id="Re60539d530d54cbc"/>
-    <p:sldId xmlns:r="http://schemas.openxmlformats.org/officeDocument/2006/relationships" id="263" r:id="R7a9359b141f646c5"/>
-    <p:sldId xmlns:r="http://schemas.openxmlformats.org/officeDocument/2006/relationships" id="264" r:id="Rfaf88703657e459c"/>
-    <p:sldId xmlns:r="http://schemas.openxmlformats.org/officeDocument/2006/relationships" id="265" r:id="R40cacff2046f46a9"/>
-    <p:sldId xmlns:r="http://schemas.openxmlformats.org/officeDocument/2006/relationships" id="266" r:id="R58be89ab509542ce"/>
+    <p:sldId xmlns:r="http://schemas.openxmlformats.org/officeDocument/2006/relationships" id="256" r:id="R69b3ffb08e4c4c4d"/>
+    <p:sldId xmlns:r="http://schemas.openxmlformats.org/officeDocument/2006/relationships" id="257" r:id="Ra12604a3785441c2"/>
+    <p:sldId xmlns:r="http://schemas.openxmlformats.org/officeDocument/2006/relationships" id="258" r:id="R4fa4e151711240ce"/>
+    <p:sldId xmlns:r="http://schemas.openxmlformats.org/officeDocument/2006/relationships" id="259" r:id="Rdf0d452deafb4c5b"/>
+    <p:sldId xmlns:r="http://schemas.openxmlformats.org/officeDocument/2006/relationships" id="260" r:id="R083c717b00ae4b36"/>
+    <p:sldId xmlns:r="http://schemas.openxmlformats.org/officeDocument/2006/relationships" id="261" r:id="R3e0af2c058fa4c73"/>
+    <p:sldId xmlns:r="http://schemas.openxmlformats.org/officeDocument/2006/relationships" id="262" r:id="Ra9c503e7640d4bc0"/>
+    <p:sldId xmlns:r="http://schemas.openxmlformats.org/officeDocument/2006/relationships" id="263" r:id="R5ff64c2d0bac4e93"/>
+    <p:sldId xmlns:r="http://schemas.openxmlformats.org/officeDocument/2006/relationships" id="264" r:id="R202112eeded64317"/>
+    <p:sldId xmlns:r="http://schemas.openxmlformats.org/officeDocument/2006/relationships" id="265" r:id="Rc8d68c3f3dc44116"/>
+    <p:sldId xmlns:r="http://schemas.openxmlformats.org/officeDocument/2006/relationships" id="266" r:id="R67ed6952b2c84615"/>
   </p:sldIdLst>
   <p:sldSz cx="7559993" cy="10691813"/>
   <p:notesSz cx="6858000" cy="9144000"/>
@@ -1254,7 +1254,7 @@
           <p:cNvPr id="3" name="Title">
             <a:extLst xmlns:a="http://schemas.openxmlformats.org/drawingml/2006/main">
               <a:ext uri="{FF2B5EF4-FFF2-40B4-BE49-F238E27FC236}">
-                <a16:creationId xmlns:a16="http://schemas.microsoft.com/office/drawing/2014/main" id="{548BB746-670E-44C9-840F-DA2E9B6B5F04}"/>
+                <a16:creationId xmlns:a16="http://schemas.microsoft.com/office/drawing/2014/main" id="{FD00F0DB-6BE7-4341-84B2-5E1CE607FDB2}"/>
               </a:ext>
             </a:extLst>
           </p:cNvPr>
@@ -1483,7 +1483,7 @@
           <p:cNvPr id="2" name="Subtitle">
             <a:extLst xmlns:a="http://schemas.openxmlformats.org/drawingml/2006/main">
               <a:ext uri="{FF2B5EF4-FFF2-40B4-BE49-F238E27FC236}">
-                <a16:creationId xmlns:a16="http://schemas.microsoft.com/office/drawing/2014/main" id="{366D5C18-E433-4D71-97BB-F17CCB9CB107}"/>
+                <a16:creationId xmlns:a16="http://schemas.microsoft.com/office/drawing/2014/main" id="{862F23FF-F469-4231-8A3F-9ABFEC017518}"/>
               </a:ext>
             </a:extLst>
           </p:cNvPr>
@@ -1729,7 +1729,7 @@
           <p:cNvPr id="2" name="Section title">
             <a:extLst xmlns:a="http://schemas.openxmlformats.org/drawingml/2006/main">
               <a:ext uri="{FF2B5EF4-FFF2-40B4-BE49-F238E27FC236}">
-                <a16:creationId xmlns:a16="http://schemas.microsoft.com/office/drawing/2014/main" id="{A8696AFD-9036-40B8-8336-8842DA82AB93}"/>
+                <a16:creationId xmlns:a16="http://schemas.microsoft.com/office/drawing/2014/main" id="{2B14D96D-AC7B-4126-8749-18A0BA95716B}"/>
               </a:ext>
             </a:extLst>
           </p:cNvPr>
@@ -1975,7 +1975,7 @@
           <p:cNvPr id="3" name="Title">
             <a:extLst xmlns:a="http://schemas.openxmlformats.org/drawingml/2006/main">
               <a:ext uri="{FF2B5EF4-FFF2-40B4-BE49-F238E27FC236}">
-                <a16:creationId xmlns:a16="http://schemas.microsoft.com/office/drawing/2014/main" id="{90B86598-8A56-46A9-8008-C94F1696865D}"/>
+                <a16:creationId xmlns:a16="http://schemas.microsoft.com/office/drawing/2014/main" id="{3953F83B-FF57-4A12-8205-A40D8BFCBCCF}"/>
               </a:ext>
             </a:extLst>
           </p:cNvPr>
@@ -2204,7 +2204,7 @@
           <p:cNvPr id="2" name="Body">
             <a:extLst xmlns:a="http://schemas.openxmlformats.org/drawingml/2006/main">
               <a:ext uri="{FF2B5EF4-FFF2-40B4-BE49-F238E27FC236}">
-                <a16:creationId xmlns:a16="http://schemas.microsoft.com/office/drawing/2014/main" id="{BC601FD6-7C59-44F1-B400-43B27217E19A}"/>
+                <a16:creationId xmlns:a16="http://schemas.microsoft.com/office/drawing/2014/main" id="{3CF261B7-DD9E-40F1-90E4-ADB9C3AC050C}"/>
               </a:ext>
             </a:extLst>
           </p:cNvPr>
@@ -2450,7 +2450,7 @@
           <p:cNvPr id="4" name="Title">
             <a:extLst xmlns:a="http://schemas.openxmlformats.org/drawingml/2006/main">
               <a:ext uri="{FF2B5EF4-FFF2-40B4-BE49-F238E27FC236}">
-                <a16:creationId xmlns:a16="http://schemas.microsoft.com/office/drawing/2014/main" id="{6356BA92-E251-4D81-B428-89D34E885E16}"/>
+                <a16:creationId xmlns:a16="http://schemas.microsoft.com/office/drawing/2014/main" id="{01E2D0A4-0274-446C-8F7C-7A5A2CEB4163}"/>
               </a:ext>
             </a:extLst>
           </p:cNvPr>
@@ -2679,7 +2679,7 @@
           <p:cNvPr id="2" name="Left column">
             <a:extLst xmlns:a="http://schemas.openxmlformats.org/drawingml/2006/main">
               <a:ext uri="{FF2B5EF4-FFF2-40B4-BE49-F238E27FC236}">
-                <a16:creationId xmlns:a16="http://schemas.microsoft.com/office/drawing/2014/main" id="{80BCC535-E5EF-4689-A7EB-4F1424FC50C7}"/>
+                <a16:creationId xmlns:a16="http://schemas.microsoft.com/office/drawing/2014/main" id="{0856FDC4-B50F-4F31-A7CB-03743DDB0768}"/>
               </a:ext>
             </a:extLst>
           </p:cNvPr>
@@ -2908,7 +2908,7 @@
           <p:cNvPr id="3" name="Right column">
             <a:extLst xmlns:a="http://schemas.openxmlformats.org/drawingml/2006/main">
               <a:ext uri="{FF2B5EF4-FFF2-40B4-BE49-F238E27FC236}">
-                <a16:creationId xmlns:a16="http://schemas.microsoft.com/office/drawing/2014/main" id="{292B415D-874C-4CFD-B7E0-54A0331384AA}"/>
+                <a16:creationId xmlns:a16="http://schemas.microsoft.com/office/drawing/2014/main" id="{B584D452-4DD6-4247-850D-87040BD96D54}"/>
               </a:ext>
             </a:extLst>
           </p:cNvPr>
@@ -3154,7 +3154,7 @@
           <p:cNvPr id="3" name="Title">
             <a:extLst xmlns:a="http://schemas.openxmlformats.org/drawingml/2006/main">
               <a:ext uri="{FF2B5EF4-FFF2-40B4-BE49-F238E27FC236}">
-                <a16:creationId xmlns:a16="http://schemas.microsoft.com/office/drawing/2014/main" id="{8759C848-492C-4C35-8D6B-A61AB076E9AD}"/>
+                <a16:creationId xmlns:a16="http://schemas.microsoft.com/office/drawing/2014/main" id="{E8B9765B-A56C-4E84-845F-4B30167FE1D4}"/>
               </a:ext>
             </a:extLst>
           </p:cNvPr>
@@ -3383,7 +3383,7 @@
           <p:cNvPr id="2" name="Left column">
             <a:extLst xmlns:a="http://schemas.openxmlformats.org/drawingml/2006/main">
               <a:ext uri="{FF2B5EF4-FFF2-40B4-BE49-F238E27FC236}">
-                <a16:creationId xmlns:a16="http://schemas.microsoft.com/office/drawing/2014/main" id="{255F9FD9-A152-49B3-8CCE-B5DA65FEB2AD}"/>
+                <a16:creationId xmlns:a16="http://schemas.microsoft.com/office/drawing/2014/main" id="{0CA7C1A3-AEF7-4321-B673-90B88956B113}"/>
               </a:ext>
             </a:extLst>
           </p:cNvPr>
@@ -3650,12 +3650,12 @@
   </p:cSld>
   <p:clrMap bg1="lt1" tx1="dk1" bg2="lt2" tx2="dk2" accent1="accent1" accent2="accent2" accent3="accent3" accent4="accent4" accent5="accent5" accent6="accent6" hlink="hlink" folHlink="folHlink"/>
   <p:sldLayoutIdLst>
-    <p:sldLayoutId xmlns:r="http://schemas.openxmlformats.org/officeDocument/2006/relationships" id="2147483649" r:id="Ra4a97203473a4171"/>
-    <p:sldLayoutId xmlns:r="http://schemas.openxmlformats.org/officeDocument/2006/relationships" id="2147483650" r:id="R9838cb1f32f14cb8"/>
-    <p:sldLayoutId xmlns:r="http://schemas.openxmlformats.org/officeDocument/2006/relationships" id="2147483651" r:id="R33ae7f89ed414a32"/>
-    <p:sldLayoutId xmlns:r="http://schemas.openxmlformats.org/officeDocument/2006/relationships" id="2147483652" r:id="Ra23aca2a78e24fe7"/>
-    <p:sldLayoutId xmlns:r="http://schemas.openxmlformats.org/officeDocument/2006/relationships" id="2147483653" r:id="Rbb4958655ec14aa3"/>
-    <p:sldLayoutId xmlns:r="http://schemas.openxmlformats.org/officeDocument/2006/relationships" id="2147483654" r:id="R554c6d8dd6b14b9b"/>
+    <p:sldLayoutId xmlns:r="http://schemas.openxmlformats.org/officeDocument/2006/relationships" id="2147483649" r:id="Rc8704e75ad0f4e0e"/>
+    <p:sldLayoutId xmlns:r="http://schemas.openxmlformats.org/officeDocument/2006/relationships" id="2147483650" r:id="R80cbd8ac21cd46fb"/>
+    <p:sldLayoutId xmlns:r="http://schemas.openxmlformats.org/officeDocument/2006/relationships" id="2147483651" r:id="R7247d3b7a5984326"/>
+    <p:sldLayoutId xmlns:r="http://schemas.openxmlformats.org/officeDocument/2006/relationships" id="2147483652" r:id="Rcf0cdcacdec04696"/>
+    <p:sldLayoutId xmlns:r="http://schemas.openxmlformats.org/officeDocument/2006/relationships" id="2147483653" r:id="Rce9b85f88dab46ad"/>
+    <p:sldLayoutId xmlns:r="http://schemas.openxmlformats.org/officeDocument/2006/relationships" id="2147483654" r:id="Ra155832ae1484028"/>
   </p:sldLayoutIdLst>
   <p:txStyles>
     <p:titleStyle>
@@ -4199,7 +4199,7 @@
           <p:cNvPr id="2" name="">
             <a:extLst xmlns:a="http://schemas.openxmlformats.org/drawingml/2006/main">
               <a:ext uri="{FF2B5EF4-FFF2-40B4-BE49-F238E27FC236}">
-                <a16:creationId xmlns:a16="http://schemas.microsoft.com/office/drawing/2014/main" id="{B372673C-C3E9-46B1-99FB-FA43F233CD19}"/>
+                <a16:creationId xmlns:a16="http://schemas.microsoft.com/office/drawing/2014/main" id="{72910EBA-FDA4-4EFE-AB4C-C2FC5D1D7FEC}"/>
               </a:ext>
             </a:extLst>
           </p:cNvPr>
@@ -4209,7 +4209,7 @@
           <p:nvPr/>
         </p:nvPicPr>
         <p:blipFill>
-          <a:blip xmlns:r="http://schemas.openxmlformats.org/officeDocument/2006/relationships" xmlns:a="http://schemas.openxmlformats.org/drawingml/2006/main" r:embed="Re721f7c7f9834134"/>
+          <a:blip xmlns:r="http://schemas.openxmlformats.org/officeDocument/2006/relationships" xmlns:a="http://schemas.openxmlformats.org/drawingml/2006/main" r:embed="Rff7a25908a2942c0"/>
           <a:stretch xmlns:a="http://schemas.openxmlformats.org/drawingml/2006/main"/>
         </p:blipFill>
         <p:spPr>
@@ -4225,7 +4225,7 @@
     </p:spTree>
     <p:extLst>
       <p:ext uri="{BB962C8B-B14F-4D97-AF65-F5344CB8AC3E}">
-        <p14:creationId xmlns:p14="http://schemas.microsoft.com/office/powerpoint/2010/main" val="969446606"/>
+        <p14:creationId xmlns:p14="http://schemas.microsoft.com/office/powerpoint/2010/main" val="2043330830"/>
       </p:ext>
     </p:extLst>
   </p:cSld>
@@ -4249,7 +4249,7 @@
           <p:cNvPr id="2" name="">
             <a:extLst xmlns:a="http://schemas.openxmlformats.org/drawingml/2006/main">
               <a:ext uri="{FF2B5EF4-FFF2-40B4-BE49-F238E27FC236}">
-                <a16:creationId xmlns:a16="http://schemas.microsoft.com/office/drawing/2014/main" id="{221324CF-DCBC-44A7-97CF-52945F2FF1FD}"/>
+                <a16:creationId xmlns:a16="http://schemas.microsoft.com/office/drawing/2014/main" id="{EB1C7F92-CB1A-440D-8356-7B79ADEF0197}"/>
               </a:ext>
             </a:extLst>
           </p:cNvPr>
@@ -4259,7 +4259,7 @@
           <p:nvPr/>
         </p:nvPicPr>
         <p:blipFill>
-          <a:blip xmlns:r="http://schemas.openxmlformats.org/officeDocument/2006/relationships" xmlns:a="http://schemas.openxmlformats.org/drawingml/2006/main" r:embed="Rd18786c0019042f3"/>
+          <a:blip xmlns:r="http://schemas.openxmlformats.org/officeDocument/2006/relationships" xmlns:a="http://schemas.openxmlformats.org/drawingml/2006/main" r:embed="Rf82ef0b9fc9a4e4c"/>
           <a:stretch xmlns:a="http://schemas.openxmlformats.org/drawingml/2006/main"/>
         </p:blipFill>
         <p:spPr>
@@ -4275,7 +4275,7 @@
     </p:spTree>
     <p:extLst>
       <p:ext uri="{BB962C8B-B14F-4D97-AF65-F5344CB8AC3E}">
-        <p14:creationId xmlns:p14="http://schemas.microsoft.com/office/powerpoint/2010/main" val="1999554049"/>
+        <p14:creationId xmlns:p14="http://schemas.microsoft.com/office/powerpoint/2010/main" val="428629567"/>
       </p:ext>
     </p:extLst>
   </p:cSld>
@@ -4299,7 +4299,7 @@
           <p:cNvPr id="2" name="">
             <a:extLst xmlns:a="http://schemas.openxmlformats.org/drawingml/2006/main">
               <a:ext uri="{FF2B5EF4-FFF2-40B4-BE49-F238E27FC236}">
-                <a16:creationId xmlns:a16="http://schemas.microsoft.com/office/drawing/2014/main" id="{9835FBF7-3541-453E-8B9A-FBB4499BA304}"/>
+                <a16:creationId xmlns:a16="http://schemas.microsoft.com/office/drawing/2014/main" id="{D56CC9DB-A7A5-48F7-81AF-BD8222E7D653}"/>
               </a:ext>
             </a:extLst>
           </p:cNvPr>
@@ -4309,7 +4309,7 @@
           <p:nvPr/>
         </p:nvPicPr>
         <p:blipFill>
-          <a:blip xmlns:r="http://schemas.openxmlformats.org/officeDocument/2006/relationships" xmlns:a="http://schemas.openxmlformats.org/drawingml/2006/main" r:embed="R0b18344b44e44566"/>
+          <a:blip xmlns:r="http://schemas.openxmlformats.org/officeDocument/2006/relationships" xmlns:a="http://schemas.openxmlformats.org/drawingml/2006/main" r:embed="Re4c724593b1840bb"/>
           <a:stretch xmlns:a="http://schemas.openxmlformats.org/drawingml/2006/main"/>
         </p:blipFill>
         <p:spPr>
@@ -4325,7 +4325,7 @@
     </p:spTree>
     <p:extLst>
       <p:ext uri="{BB962C8B-B14F-4D97-AF65-F5344CB8AC3E}">
-        <p14:creationId xmlns:p14="http://schemas.microsoft.com/office/powerpoint/2010/main" val="1982589386"/>
+        <p14:creationId xmlns:p14="http://schemas.microsoft.com/office/powerpoint/2010/main" val="235374255"/>
       </p:ext>
     </p:extLst>
   </p:cSld>
@@ -4349,7 +4349,7 @@
           <p:cNvPr id="2" name="">
             <a:extLst xmlns:a="http://schemas.openxmlformats.org/drawingml/2006/main">
               <a:ext uri="{FF2B5EF4-FFF2-40B4-BE49-F238E27FC236}">
-                <a16:creationId xmlns:a16="http://schemas.microsoft.com/office/drawing/2014/main" id="{1A2C27B7-F895-4A1F-A2B8-8ADA9C7C83AE}"/>
+                <a16:creationId xmlns:a16="http://schemas.microsoft.com/office/drawing/2014/main" id="{9CC3D982-898F-4A76-9FF9-E5F18387D97F}"/>
               </a:ext>
             </a:extLst>
           </p:cNvPr>
@@ -4359,7 +4359,7 @@
           <p:nvPr/>
         </p:nvPicPr>
         <p:blipFill>
-          <a:blip xmlns:r="http://schemas.openxmlformats.org/officeDocument/2006/relationships" xmlns:a="http://schemas.openxmlformats.org/drawingml/2006/main" r:embed="Raea04d16482449f5"/>
+          <a:blip xmlns:r="http://schemas.openxmlformats.org/officeDocument/2006/relationships" xmlns:a="http://schemas.openxmlformats.org/drawingml/2006/main" r:embed="R78e0d08cfa0f48cc"/>
           <a:stretch xmlns:a="http://schemas.openxmlformats.org/drawingml/2006/main"/>
         </p:blipFill>
         <p:spPr>
@@ -4375,7 +4375,7 @@
     </p:spTree>
     <p:extLst>
       <p:ext uri="{BB962C8B-B14F-4D97-AF65-F5344CB8AC3E}">
-        <p14:creationId xmlns:p14="http://schemas.microsoft.com/office/powerpoint/2010/main" val="1749246965"/>
+        <p14:creationId xmlns:p14="http://schemas.microsoft.com/office/powerpoint/2010/main" val="2027840940"/>
       </p:ext>
     </p:extLst>
   </p:cSld>
@@ -4399,7 +4399,7 @@
           <p:cNvPr id="2" name="">
             <a:extLst xmlns:a="http://schemas.openxmlformats.org/drawingml/2006/main">
               <a:ext uri="{FF2B5EF4-FFF2-40B4-BE49-F238E27FC236}">
-                <a16:creationId xmlns:a16="http://schemas.microsoft.com/office/drawing/2014/main" id="{962095CF-25D7-40C5-ABFB-B5143EFAB917}"/>
+                <a16:creationId xmlns:a16="http://schemas.microsoft.com/office/drawing/2014/main" id="{C60ABD60-4F1F-45C5-9554-EBEF34A5B642}"/>
               </a:ext>
             </a:extLst>
           </p:cNvPr>
@@ -4409,7 +4409,7 @@
           <p:nvPr/>
         </p:nvPicPr>
         <p:blipFill>
-          <a:blip xmlns:r="http://schemas.openxmlformats.org/officeDocument/2006/relationships" xmlns:a="http://schemas.openxmlformats.org/drawingml/2006/main" r:embed="Rb71577dc33b64dc1"/>
+          <a:blip xmlns:r="http://schemas.openxmlformats.org/officeDocument/2006/relationships" xmlns:a="http://schemas.openxmlformats.org/drawingml/2006/main" r:embed="Reb3506c23c05409d"/>
           <a:stretch xmlns:a="http://schemas.openxmlformats.org/drawingml/2006/main"/>
         </p:blipFill>
         <p:spPr>
@@ -4425,7 +4425,7 @@
     </p:spTree>
     <p:extLst>
       <p:ext uri="{BB962C8B-B14F-4D97-AF65-F5344CB8AC3E}">
-        <p14:creationId xmlns:p14="http://schemas.microsoft.com/office/powerpoint/2010/main" val="1833555837"/>
+        <p14:creationId xmlns:p14="http://schemas.microsoft.com/office/powerpoint/2010/main" val="1752361745"/>
       </p:ext>
     </p:extLst>
   </p:cSld>
@@ -4449,7 +4449,7 @@
           <p:cNvPr id="2" name="">
             <a:extLst xmlns:a="http://schemas.openxmlformats.org/drawingml/2006/main">
               <a:ext uri="{FF2B5EF4-FFF2-40B4-BE49-F238E27FC236}">
-                <a16:creationId xmlns:a16="http://schemas.microsoft.com/office/drawing/2014/main" id="{717F8E63-7C62-4CA4-B823-3B77602A11D5}"/>
+                <a16:creationId xmlns:a16="http://schemas.microsoft.com/office/drawing/2014/main" id="{90EE3884-DEF3-4F39-BEC5-763FFA77C82D}"/>
               </a:ext>
             </a:extLst>
           </p:cNvPr>
@@ -4459,7 +4459,7 @@
           <p:nvPr/>
         </p:nvPicPr>
         <p:blipFill>
-          <a:blip xmlns:r="http://schemas.openxmlformats.org/officeDocument/2006/relationships" xmlns:a="http://schemas.openxmlformats.org/drawingml/2006/main" r:embed="Rd59557406f9846b2"/>
+          <a:blip xmlns:r="http://schemas.openxmlformats.org/officeDocument/2006/relationships" xmlns:a="http://schemas.openxmlformats.org/drawingml/2006/main" r:embed="R495ad0d79c7b4979"/>
           <a:stretch xmlns:a="http://schemas.openxmlformats.org/drawingml/2006/main"/>
         </p:blipFill>
         <p:spPr>
@@ -4475,7 +4475,7 @@
     </p:spTree>
     <p:extLst>
       <p:ext uri="{BB962C8B-B14F-4D97-AF65-F5344CB8AC3E}">
-        <p14:creationId xmlns:p14="http://schemas.microsoft.com/office/powerpoint/2010/main" val="418958871"/>
+        <p14:creationId xmlns:p14="http://schemas.microsoft.com/office/powerpoint/2010/main" val="19786562"/>
       </p:ext>
     </p:extLst>
   </p:cSld>
@@ -4499,7 +4499,7 @@
           <p:cNvPr id="2" name="">
             <a:extLst xmlns:a="http://schemas.openxmlformats.org/drawingml/2006/main">
               <a:ext uri="{FF2B5EF4-FFF2-40B4-BE49-F238E27FC236}">
-                <a16:creationId xmlns:a16="http://schemas.microsoft.com/office/drawing/2014/main" id="{A9238951-1732-4225-B030-B9940270A1E9}"/>
+                <a16:creationId xmlns:a16="http://schemas.microsoft.com/office/drawing/2014/main" id="{704A562D-D0B2-4E9C-9982-E27C97EC410C}"/>
               </a:ext>
             </a:extLst>
           </p:cNvPr>
@@ -4509,7 +4509,7 @@
           <p:nvPr/>
         </p:nvPicPr>
         <p:blipFill>
-          <a:blip xmlns:r="http://schemas.openxmlformats.org/officeDocument/2006/relationships" xmlns:a="http://schemas.openxmlformats.org/drawingml/2006/main" r:embed="Rfa2df3fc78b24482"/>
+          <a:blip xmlns:r="http://schemas.openxmlformats.org/officeDocument/2006/relationships" xmlns:a="http://schemas.openxmlformats.org/drawingml/2006/main" r:embed="R3feb2a3498b64821"/>
           <a:stretch xmlns:a="http://schemas.openxmlformats.org/drawingml/2006/main"/>
         </p:blipFill>
         <p:spPr>
@@ -4525,7 +4525,7 @@
     </p:spTree>
     <p:extLst>
       <p:ext uri="{BB962C8B-B14F-4D97-AF65-F5344CB8AC3E}">
-        <p14:creationId xmlns:p14="http://schemas.microsoft.com/office/powerpoint/2010/main" val="180792510"/>
+        <p14:creationId xmlns:p14="http://schemas.microsoft.com/office/powerpoint/2010/main" val="541575950"/>
       </p:ext>
     </p:extLst>
   </p:cSld>
@@ -4549,7 +4549,7 @@
           <p:cNvPr id="2" name="">
             <a:extLst xmlns:a="http://schemas.openxmlformats.org/drawingml/2006/main">
               <a:ext uri="{FF2B5EF4-FFF2-40B4-BE49-F238E27FC236}">
-                <a16:creationId xmlns:a16="http://schemas.microsoft.com/office/drawing/2014/main" id="{74ECC7BC-77B1-480A-B155-97BC07AFAFAE}"/>
+                <a16:creationId xmlns:a16="http://schemas.microsoft.com/office/drawing/2014/main" id="{66EF36DA-DBB5-43B2-9877-608A93BFB338}"/>
               </a:ext>
             </a:extLst>
           </p:cNvPr>
@@ -4559,7 +4559,7 @@
           <p:nvPr/>
         </p:nvPicPr>
         <p:blipFill>
-          <a:blip xmlns:r="http://schemas.openxmlformats.org/officeDocument/2006/relationships" xmlns:a="http://schemas.openxmlformats.org/drawingml/2006/main" r:embed="R25d1226a587441c3"/>
+          <a:blip xmlns:r="http://schemas.openxmlformats.org/officeDocument/2006/relationships" xmlns:a="http://schemas.openxmlformats.org/drawingml/2006/main" r:embed="Rada45bad0a6e47cd"/>
           <a:stretch xmlns:a="http://schemas.openxmlformats.org/drawingml/2006/main"/>
         </p:blipFill>
         <p:spPr>
@@ -4575,7 +4575,7 @@
     </p:spTree>
     <p:extLst>
       <p:ext uri="{BB962C8B-B14F-4D97-AF65-F5344CB8AC3E}">
-        <p14:creationId xmlns:p14="http://schemas.microsoft.com/office/powerpoint/2010/main" val="1619659488"/>
+        <p14:creationId xmlns:p14="http://schemas.microsoft.com/office/powerpoint/2010/main" val="1446337934"/>
       </p:ext>
     </p:extLst>
   </p:cSld>
@@ -4599,7 +4599,7 @@
           <p:cNvPr id="2" name="">
             <a:extLst xmlns:a="http://schemas.openxmlformats.org/drawingml/2006/main">
               <a:ext uri="{FF2B5EF4-FFF2-40B4-BE49-F238E27FC236}">
-                <a16:creationId xmlns:a16="http://schemas.microsoft.com/office/drawing/2014/main" id="{9090D579-EDDD-4C01-87E4-3DBEA5FD4155}"/>
+                <a16:creationId xmlns:a16="http://schemas.microsoft.com/office/drawing/2014/main" id="{9DB7C111-E896-43B6-8702-53854D22C7A1}"/>
               </a:ext>
             </a:extLst>
           </p:cNvPr>
@@ -4609,7 +4609,7 @@
           <p:nvPr/>
         </p:nvPicPr>
         <p:blipFill>
-          <a:blip xmlns:r="http://schemas.openxmlformats.org/officeDocument/2006/relationships" xmlns:a="http://schemas.openxmlformats.org/drawingml/2006/main" r:embed="R8841a2ef632f4bff"/>
+          <a:blip xmlns:r="http://schemas.openxmlformats.org/officeDocument/2006/relationships" xmlns:a="http://schemas.openxmlformats.org/drawingml/2006/main" r:embed="R4026520dd0c642e1"/>
           <a:stretch xmlns:a="http://schemas.openxmlformats.org/drawingml/2006/main"/>
         </p:blipFill>
         <p:spPr>
@@ -4625,7 +4625,7 @@
     </p:spTree>
     <p:extLst>
       <p:ext uri="{BB962C8B-B14F-4D97-AF65-F5344CB8AC3E}">
-        <p14:creationId xmlns:p14="http://schemas.microsoft.com/office/powerpoint/2010/main" val="2019482171"/>
+        <p14:creationId xmlns:p14="http://schemas.microsoft.com/office/powerpoint/2010/main" val="445500905"/>
       </p:ext>
     </p:extLst>
   </p:cSld>
@@ -4649,7 +4649,7 @@
           <p:cNvPr id="2" name="">
             <a:extLst xmlns:a="http://schemas.openxmlformats.org/drawingml/2006/main">
               <a:ext uri="{FF2B5EF4-FFF2-40B4-BE49-F238E27FC236}">
-                <a16:creationId xmlns:a16="http://schemas.microsoft.com/office/drawing/2014/main" id="{7ADD4F94-EE7F-4246-A15E-B8C212B5E29B}"/>
+                <a16:creationId xmlns:a16="http://schemas.microsoft.com/office/drawing/2014/main" id="{3715ADD5-A178-4003-82FF-4B8A26E9945A}"/>
               </a:ext>
             </a:extLst>
           </p:cNvPr>
@@ -4659,7 +4659,7 @@
           <p:nvPr/>
         </p:nvPicPr>
         <p:blipFill>
-          <a:blip xmlns:r="http://schemas.openxmlformats.org/officeDocument/2006/relationships" xmlns:a="http://schemas.openxmlformats.org/drawingml/2006/main" r:embed="Rdbde554e6a2b4939"/>
+          <a:blip xmlns:r="http://schemas.openxmlformats.org/officeDocument/2006/relationships" xmlns:a="http://schemas.openxmlformats.org/drawingml/2006/main" r:embed="R4e869d7ddcb84fee"/>
           <a:stretch xmlns:a="http://schemas.openxmlformats.org/drawingml/2006/main"/>
         </p:blipFill>
         <p:spPr>
@@ -4675,7 +4675,7 @@
     </p:spTree>
     <p:extLst>
       <p:ext uri="{BB962C8B-B14F-4D97-AF65-F5344CB8AC3E}">
-        <p14:creationId xmlns:p14="http://schemas.microsoft.com/office/powerpoint/2010/main" val="829145902"/>
+        <p14:creationId xmlns:p14="http://schemas.microsoft.com/office/powerpoint/2010/main" val="1785903931"/>
       </p:ext>
     </p:extLst>
   </p:cSld>
@@ -4699,7 +4699,7 @@
           <p:cNvPr id="2" name="">
             <a:extLst xmlns:a="http://schemas.openxmlformats.org/drawingml/2006/main">
               <a:ext uri="{FF2B5EF4-FFF2-40B4-BE49-F238E27FC236}">
-                <a16:creationId xmlns:a16="http://schemas.microsoft.com/office/drawing/2014/main" id="{A3B00F04-5D84-4C58-9165-426F5849D6CE}"/>
+                <a16:creationId xmlns:a16="http://schemas.microsoft.com/office/drawing/2014/main" id="{8A38F2ED-7556-4717-AE29-684792AF3E95}"/>
               </a:ext>
             </a:extLst>
           </p:cNvPr>
@@ -4709,7 +4709,7 @@
           <p:nvPr/>
         </p:nvPicPr>
         <p:blipFill>
-          <a:blip xmlns:r="http://schemas.openxmlformats.org/officeDocument/2006/relationships" xmlns:a="http://schemas.openxmlformats.org/drawingml/2006/main" r:embed="R0e4556f437a349a7"/>
+          <a:blip xmlns:r="http://schemas.openxmlformats.org/officeDocument/2006/relationships" xmlns:a="http://schemas.openxmlformats.org/drawingml/2006/main" r:embed="R800fe403dc4642c2"/>
           <a:stretch xmlns:a="http://schemas.openxmlformats.org/drawingml/2006/main"/>
         </p:blipFill>
         <p:spPr>
@@ -4725,7 +4725,7 @@
     </p:spTree>
     <p:extLst>
       <p:ext uri="{BB962C8B-B14F-4D97-AF65-F5344CB8AC3E}">
-        <p14:creationId xmlns:p14="http://schemas.microsoft.com/office/powerpoint/2010/main" val="665815716"/>
+        <p14:creationId xmlns:p14="http://schemas.microsoft.com/office/powerpoint/2010/main" val="1676135447"/>
       </p:ext>
     </p:extLst>
   </p:cSld>

</xml_diff>